<commit_message>
Deploying to gh-pages from @ sagreslab/sagreslab.github.io@6f3b3e080d775ed2e9d6029cde0aaa7c06e5f8bd 🚀
</commit_message>
<xml_diff>
--- a/images/banner.pptx
+++ b/images/banner.pptx
@@ -8,6 +8,7 @@
     <p:sldId id="256" r:id="rId2"/>
     <p:sldId id="257" r:id="rId3"/>
     <p:sldId id="259" r:id="rId4"/>
+    <p:sldId id="260" r:id="rId5"/>
   </p:sldIdLst>
   <p:sldSz cx="12192000" cy="6858000"/>
   <p:notesSz cx="6858000" cy="9144000"/>
@@ -496,7 +497,7 @@
           <a:p>
             <a:fld id="{DAFF87E1-C8BB-4CE2-A21E-0C11E3CF7165}" type="datetimeFigureOut">
               <a:rPr lang="en-US" smtClean="0"/>
-              <a:t>8/24/2026</a:t>
+              <a:t>10/20/2026</a:t>
             </a:fld>
             <a:endParaRPr lang="en-US"/>
           </a:p>
@@ -694,7 +695,7 @@
           <a:p>
             <a:fld id="{DAFF87E1-C8BB-4CE2-A21E-0C11E3CF7165}" type="datetimeFigureOut">
               <a:rPr lang="en-US" smtClean="0"/>
-              <a:t>8/24/2026</a:t>
+              <a:t>10/20/2026</a:t>
             </a:fld>
             <a:endParaRPr lang="en-US"/>
           </a:p>
@@ -902,7 +903,7 @@
           <a:p>
             <a:fld id="{DAFF87E1-C8BB-4CE2-A21E-0C11E3CF7165}" type="datetimeFigureOut">
               <a:rPr lang="en-US" smtClean="0"/>
-              <a:t>8/24/2026</a:t>
+              <a:t>10/20/2026</a:t>
             </a:fld>
             <a:endParaRPr lang="en-US"/>
           </a:p>
@@ -1100,7 +1101,7 @@
           <a:p>
             <a:fld id="{DAFF87E1-C8BB-4CE2-A21E-0C11E3CF7165}" type="datetimeFigureOut">
               <a:rPr lang="en-US" smtClean="0"/>
-              <a:t>8/24/2026</a:t>
+              <a:t>10/20/2026</a:t>
             </a:fld>
             <a:endParaRPr lang="en-US"/>
           </a:p>
@@ -1375,7 +1376,7 @@
           <a:p>
             <a:fld id="{DAFF87E1-C8BB-4CE2-A21E-0C11E3CF7165}" type="datetimeFigureOut">
               <a:rPr lang="en-US" smtClean="0"/>
-              <a:t>8/24/2026</a:t>
+              <a:t>10/20/2026</a:t>
             </a:fld>
             <a:endParaRPr lang="en-US"/>
           </a:p>
@@ -1640,7 +1641,7 @@
           <a:p>
             <a:fld id="{DAFF87E1-C8BB-4CE2-A21E-0C11E3CF7165}" type="datetimeFigureOut">
               <a:rPr lang="en-US" smtClean="0"/>
-              <a:t>8/24/2026</a:t>
+              <a:t>10/20/2026</a:t>
             </a:fld>
             <a:endParaRPr lang="en-US"/>
           </a:p>
@@ -2052,7 +2053,7 @@
           <a:p>
             <a:fld id="{DAFF87E1-C8BB-4CE2-A21E-0C11E3CF7165}" type="datetimeFigureOut">
               <a:rPr lang="en-US" smtClean="0"/>
-              <a:t>8/24/2026</a:t>
+              <a:t>10/20/2026</a:t>
             </a:fld>
             <a:endParaRPr lang="en-US"/>
           </a:p>
@@ -2193,7 +2194,7 @@
           <a:p>
             <a:fld id="{DAFF87E1-C8BB-4CE2-A21E-0C11E3CF7165}" type="datetimeFigureOut">
               <a:rPr lang="en-US" smtClean="0"/>
-              <a:t>8/24/2026</a:t>
+              <a:t>10/20/2026</a:t>
             </a:fld>
             <a:endParaRPr lang="en-US"/>
           </a:p>
@@ -2306,7 +2307,7 @@
           <a:p>
             <a:fld id="{DAFF87E1-C8BB-4CE2-A21E-0C11E3CF7165}" type="datetimeFigureOut">
               <a:rPr lang="en-US" smtClean="0"/>
-              <a:t>8/24/2026</a:t>
+              <a:t>10/20/2026</a:t>
             </a:fld>
             <a:endParaRPr lang="en-US"/>
           </a:p>
@@ -2617,7 +2618,7 @@
           <a:p>
             <a:fld id="{DAFF87E1-C8BB-4CE2-A21E-0C11E3CF7165}" type="datetimeFigureOut">
               <a:rPr lang="en-US" smtClean="0"/>
-              <a:t>8/24/2026</a:t>
+              <a:t>10/20/2026</a:t>
             </a:fld>
             <a:endParaRPr lang="en-US"/>
           </a:p>
@@ -2905,7 +2906,7 @@
           <a:p>
             <a:fld id="{DAFF87E1-C8BB-4CE2-A21E-0C11E3CF7165}" type="datetimeFigureOut">
               <a:rPr lang="en-US" smtClean="0"/>
-              <a:t>8/24/2026</a:t>
+              <a:t>10/20/2026</a:t>
             </a:fld>
             <a:endParaRPr lang="en-US"/>
           </a:p>
@@ -3146,7 +3147,7 @@
           <a:p>
             <a:fld id="{DAFF87E1-C8BB-4CE2-A21E-0C11E3CF7165}" type="datetimeFigureOut">
               <a:rPr lang="en-US" smtClean="0"/>
-              <a:t>8/24/2026</a:t>
+              <a:t>10/20/2026</a:t>
             </a:fld>
             <a:endParaRPr lang="en-US"/>
           </a:p>
@@ -4913,10 +4914,418 @@
           </a:p>
         </p:txBody>
       </p:sp>
+      <p:pic>
+        <p:nvPicPr>
+          <p:cNvPr id="7" name="Picture 6">
+            <a:extLst>
+              <a:ext uri="{FF2B5EF4-FFF2-40B4-BE49-F238E27FC236}">
+                <a16:creationId xmlns:a16="http://schemas.microsoft.com/office/drawing/2014/main" id="{538E0EF9-DEAD-3E4E-D95E-57AEBC6211DD}"/>
+              </a:ext>
+            </a:extLst>
+          </p:cNvPr>
+          <p:cNvPicPr>
+            <a:picLocks noChangeAspect="1"/>
+          </p:cNvPicPr>
+          <p:nvPr/>
+        </p:nvPicPr>
+        <p:blipFill>
+          <a:blip r:embed="rId3">
+            <a:extLst>
+              <a:ext uri="{28A0092B-C50C-407E-A947-70E740481C1C}">
+                <a14:useLocalDpi xmlns:a14="http://schemas.microsoft.com/office/drawing/2010/main" val="0"/>
+              </a:ext>
+            </a:extLst>
+          </a:blip>
+          <a:stretch>
+            <a:fillRect/>
+          </a:stretch>
+        </p:blipFill>
+        <p:spPr>
+          <a:xfrm>
+            <a:off x="5604897" y="5436336"/>
+            <a:ext cx="1324722" cy="1442301"/>
+          </a:xfrm>
+          <a:prstGeom prst="rect">
+            <a:avLst/>
+          </a:prstGeom>
+        </p:spPr>
+      </p:pic>
     </p:spTree>
     <p:extLst>
       <p:ext uri="{BB962C8B-B14F-4D97-AF65-F5344CB8AC3E}">
         <p14:creationId xmlns:p14="http://schemas.microsoft.com/office/powerpoint/2010/main" val="206700784"/>
+      </p:ext>
+    </p:extLst>
+  </p:cSld>
+  <p:clrMapOvr>
+    <a:masterClrMapping/>
+  </p:clrMapOvr>
+</p:sld>
+</file>
+
+<file path=ppt/slides/slide4.xml><?xml version="1.0" encoding="utf-8"?>
+<p:sld xmlns:a="http://schemas.openxmlformats.org/drawingml/2006/main" xmlns:r="http://schemas.openxmlformats.org/officeDocument/2006/relationships" xmlns:p="http://schemas.openxmlformats.org/presentationml/2006/main">
+  <p:cSld>
+    <p:spTree>
+      <p:nvGrpSpPr>
+        <p:cNvPr id="1" name="">
+          <a:extLst>
+            <a:ext uri="{FF2B5EF4-FFF2-40B4-BE49-F238E27FC236}">
+              <a16:creationId xmlns:a16="http://schemas.microsoft.com/office/drawing/2014/main" id="{AF46FDDF-C6B1-B6C9-7C3F-F651AC534163}"/>
+            </a:ext>
+          </a:extLst>
+        </p:cNvPr>
+        <p:cNvGrpSpPr/>
+        <p:nvPr/>
+      </p:nvGrpSpPr>
+      <p:grpSpPr>
+        <a:xfrm>
+          <a:off x="0" y="0"/>
+          <a:ext cx="0" cy="0"/>
+          <a:chOff x="0" y="0"/>
+          <a:chExt cx="0" cy="0"/>
+        </a:xfrm>
+      </p:grpSpPr>
+      <p:pic>
+        <p:nvPicPr>
+          <p:cNvPr id="2" name="Picture 1">
+            <a:extLst>
+              <a:ext uri="{FF2B5EF4-FFF2-40B4-BE49-F238E27FC236}">
+                <a16:creationId xmlns:a16="http://schemas.microsoft.com/office/drawing/2014/main" id="{58E29D29-F601-272B-3AA1-D0371E90A105}"/>
+              </a:ext>
+            </a:extLst>
+          </p:cNvPr>
+          <p:cNvPicPr>
+            <a:picLocks noChangeAspect="1"/>
+          </p:cNvPicPr>
+          <p:nvPr/>
+        </p:nvPicPr>
+        <p:blipFill>
+          <a:blip r:embed="rId2">
+            <a:extLst>
+              <a:ext uri="{28A0092B-C50C-407E-A947-70E740481C1C}">
+                <a14:useLocalDpi xmlns:a14="http://schemas.microsoft.com/office/drawing/2010/main" val="0"/>
+              </a:ext>
+            </a:extLst>
+          </a:blip>
+          <a:srcRect t="24472" b="21385"/>
+          <a:stretch>
+            <a:fillRect/>
+          </a:stretch>
+        </p:blipFill>
+        <p:spPr>
+          <a:xfrm>
+            <a:off x="0" y="0"/>
+            <a:ext cx="12192000" cy="2281974"/>
+          </a:xfrm>
+          <a:prstGeom prst="rect">
+            <a:avLst/>
+          </a:prstGeom>
+          <a:gradFill>
+            <a:gsLst>
+              <a:gs pos="20000">
+                <a:schemeClr val="bg1"/>
+              </a:gs>
+              <a:gs pos="48000">
+                <a:srgbClr val="00AFEB"/>
+              </a:gs>
+            </a:gsLst>
+            <a:path path="circle">
+              <a:fillToRect l="50000" t="50000" r="50000" b="50000"/>
+            </a:path>
+          </a:gradFill>
+        </p:spPr>
+      </p:pic>
+      <p:sp>
+        <p:nvSpPr>
+          <p:cNvPr id="14" name="Rectangle 13">
+            <a:extLst>
+              <a:ext uri="{FF2B5EF4-FFF2-40B4-BE49-F238E27FC236}">
+                <a16:creationId xmlns:a16="http://schemas.microsoft.com/office/drawing/2014/main" id="{FB466DBC-422B-2AC1-B7A1-D45753F40D10}"/>
+              </a:ext>
+            </a:extLst>
+          </p:cNvPr>
+          <p:cNvSpPr/>
+          <p:nvPr/>
+        </p:nvSpPr>
+        <p:spPr>
+          <a:xfrm rot="10800000">
+            <a:off x="-1" y="0"/>
+            <a:ext cx="12191999" cy="2281974"/>
+          </a:xfrm>
+          <a:prstGeom prst="rect">
+            <a:avLst/>
+          </a:prstGeom>
+          <a:solidFill>
+            <a:schemeClr val="tx1">
+              <a:alpha val="80000"/>
+            </a:schemeClr>
+          </a:solidFill>
+          <a:ln>
+            <a:noFill/>
+          </a:ln>
+        </p:spPr>
+        <p:style>
+          <a:lnRef idx="2">
+            <a:schemeClr val="accent1">
+              <a:shade val="15000"/>
+            </a:schemeClr>
+          </a:lnRef>
+          <a:fillRef idx="1">
+            <a:schemeClr val="accent1"/>
+          </a:fillRef>
+          <a:effectRef idx="0">
+            <a:schemeClr val="accent1"/>
+          </a:effectRef>
+          <a:fontRef idx="minor">
+            <a:schemeClr val="lt1"/>
+          </a:fontRef>
+        </p:style>
+        <p:txBody>
+          <a:bodyPr rtlCol="0" anchor="ctr"/>
+          <a:lstStyle/>
+          <a:p>
+            <a:pPr algn="ctr"/>
+            <a:endParaRPr lang="en-US" dirty="0"/>
+          </a:p>
+          <a:p>
+            <a:pPr algn="ctr"/>
+            <a:endParaRPr lang="en-US" dirty="0"/>
+          </a:p>
+          <a:p>
+            <a:pPr algn="ctr"/>
+            <a:endParaRPr lang="en-US" dirty="0"/>
+          </a:p>
+          <a:p>
+            <a:pPr algn="ctr"/>
+            <a:endParaRPr lang="en-US" dirty="0"/>
+          </a:p>
+          <a:p>
+            <a:pPr algn="ctr"/>
+            <a:endParaRPr lang="en-US" dirty="0"/>
+          </a:p>
+          <a:p>
+            <a:pPr algn="ctr"/>
+            <a:endParaRPr lang="en-US" dirty="0"/>
+          </a:p>
+          <a:p>
+            <a:pPr algn="ctr"/>
+            <a:endParaRPr lang="en-US" dirty="0"/>
+          </a:p>
+          <a:p>
+            <a:pPr algn="ctr"/>
+            <a:endParaRPr lang="en-US" dirty="0"/>
+          </a:p>
+          <a:p>
+            <a:pPr algn="ctr"/>
+            <a:endParaRPr lang="en-US" dirty="0"/>
+          </a:p>
+          <a:p>
+            <a:pPr algn="ctr"/>
+            <a:endParaRPr lang="en-US" dirty="0"/>
+          </a:p>
+          <a:p>
+            <a:pPr algn="ctr"/>
+            <a:endParaRPr lang="en-US" dirty="0"/>
+          </a:p>
+          <a:p>
+            <a:pPr algn="ctr"/>
+            <a:endParaRPr lang="en-US" dirty="0"/>
+          </a:p>
+          <a:p>
+            <a:pPr algn="ctr"/>
+            <a:endParaRPr lang="en-US" dirty="0"/>
+          </a:p>
+          <a:p>
+            <a:pPr algn="ctr"/>
+            <a:endParaRPr lang="en-US" dirty="0"/>
+          </a:p>
+          <a:p>
+            <a:pPr algn="ctr"/>
+            <a:endParaRPr lang="en-US" dirty="0"/>
+          </a:p>
+          <a:p>
+            <a:pPr algn="ctr"/>
+            <a:endParaRPr lang="en-US" dirty="0"/>
+          </a:p>
+          <a:p>
+            <a:pPr algn="ctr"/>
+            <a:endParaRPr lang="en-US" dirty="0"/>
+          </a:p>
+        </p:txBody>
+      </p:sp>
+      <p:pic>
+        <p:nvPicPr>
+          <p:cNvPr id="9" name="Picture 8">
+            <a:extLst>
+              <a:ext uri="{FF2B5EF4-FFF2-40B4-BE49-F238E27FC236}">
+                <a16:creationId xmlns:a16="http://schemas.microsoft.com/office/drawing/2014/main" id="{467EE1EC-89E6-589D-8889-02C8099BD32B}"/>
+              </a:ext>
+            </a:extLst>
+          </p:cNvPr>
+          <p:cNvPicPr>
+            <a:picLocks noChangeAspect="1"/>
+          </p:cNvPicPr>
+          <p:nvPr/>
+        </p:nvPicPr>
+        <p:blipFill>
+          <a:blip r:embed="rId2">
+            <a:extLst>
+              <a:ext uri="{28A0092B-C50C-407E-A947-70E740481C1C}">
+                <a14:useLocalDpi xmlns:a14="http://schemas.microsoft.com/office/drawing/2010/main" val="0"/>
+              </a:ext>
+            </a:extLst>
+          </a:blip>
+          <a:srcRect t="24472" b="21385"/>
+          <a:stretch>
+            <a:fillRect/>
+          </a:stretch>
+        </p:blipFill>
+        <p:spPr>
+          <a:xfrm>
+            <a:off x="0" y="3143250"/>
+            <a:ext cx="12192000" cy="2281974"/>
+          </a:xfrm>
+          <a:prstGeom prst="rect">
+            <a:avLst/>
+          </a:prstGeom>
+          <a:gradFill>
+            <a:gsLst>
+              <a:gs pos="20000">
+                <a:schemeClr val="bg1"/>
+              </a:gs>
+              <a:gs pos="48000">
+                <a:srgbClr val="00AFEB"/>
+              </a:gs>
+            </a:gsLst>
+            <a:path path="circle">
+              <a:fillToRect l="50000" t="50000" r="50000" b="50000"/>
+            </a:path>
+          </a:gradFill>
+        </p:spPr>
+      </p:pic>
+      <p:sp>
+        <p:nvSpPr>
+          <p:cNvPr id="10" name="Rectangle 9">
+            <a:extLst>
+              <a:ext uri="{FF2B5EF4-FFF2-40B4-BE49-F238E27FC236}">
+                <a16:creationId xmlns:a16="http://schemas.microsoft.com/office/drawing/2014/main" id="{8DF35A54-62CC-9A83-AB0D-D4714711B71B}"/>
+              </a:ext>
+            </a:extLst>
+          </p:cNvPr>
+          <p:cNvSpPr/>
+          <p:nvPr/>
+        </p:nvSpPr>
+        <p:spPr>
+          <a:xfrm rot="10800000">
+            <a:off x="-1" y="3143250"/>
+            <a:ext cx="12191999" cy="2281974"/>
+          </a:xfrm>
+          <a:prstGeom prst="rect">
+            <a:avLst/>
+          </a:prstGeom>
+          <a:solidFill>
+            <a:schemeClr val="tx1">
+              <a:alpha val="90000"/>
+            </a:schemeClr>
+          </a:solidFill>
+          <a:ln>
+            <a:noFill/>
+          </a:ln>
+        </p:spPr>
+        <p:style>
+          <a:lnRef idx="2">
+            <a:schemeClr val="accent1">
+              <a:shade val="15000"/>
+            </a:schemeClr>
+          </a:lnRef>
+          <a:fillRef idx="1">
+            <a:schemeClr val="accent1"/>
+          </a:fillRef>
+          <a:effectRef idx="0">
+            <a:schemeClr val="accent1"/>
+          </a:effectRef>
+          <a:fontRef idx="minor">
+            <a:schemeClr val="lt1"/>
+          </a:fontRef>
+        </p:style>
+        <p:txBody>
+          <a:bodyPr rtlCol="0" anchor="ctr"/>
+          <a:lstStyle/>
+          <a:p>
+            <a:pPr algn="ctr"/>
+            <a:endParaRPr lang="en-US" dirty="0"/>
+          </a:p>
+          <a:p>
+            <a:pPr algn="ctr"/>
+            <a:endParaRPr lang="en-US" dirty="0"/>
+          </a:p>
+          <a:p>
+            <a:pPr algn="ctr"/>
+            <a:endParaRPr lang="en-US" dirty="0"/>
+          </a:p>
+          <a:p>
+            <a:pPr algn="ctr"/>
+            <a:endParaRPr lang="en-US" dirty="0"/>
+          </a:p>
+          <a:p>
+            <a:pPr algn="ctr"/>
+            <a:endParaRPr lang="en-US" dirty="0"/>
+          </a:p>
+          <a:p>
+            <a:pPr algn="ctr"/>
+            <a:endParaRPr lang="en-US" dirty="0"/>
+          </a:p>
+          <a:p>
+            <a:pPr algn="ctr"/>
+            <a:endParaRPr lang="en-US" dirty="0"/>
+          </a:p>
+          <a:p>
+            <a:pPr algn="ctr"/>
+            <a:endParaRPr lang="en-US" dirty="0"/>
+          </a:p>
+          <a:p>
+            <a:pPr algn="ctr"/>
+            <a:endParaRPr lang="en-US" dirty="0"/>
+          </a:p>
+          <a:p>
+            <a:pPr algn="ctr"/>
+            <a:endParaRPr lang="en-US" dirty="0"/>
+          </a:p>
+          <a:p>
+            <a:pPr algn="ctr"/>
+            <a:endParaRPr lang="en-US" dirty="0"/>
+          </a:p>
+          <a:p>
+            <a:pPr algn="ctr"/>
+            <a:endParaRPr lang="en-US" dirty="0"/>
+          </a:p>
+          <a:p>
+            <a:pPr algn="ctr"/>
+            <a:endParaRPr lang="en-US" dirty="0"/>
+          </a:p>
+          <a:p>
+            <a:pPr algn="ctr"/>
+            <a:endParaRPr lang="en-US" dirty="0"/>
+          </a:p>
+          <a:p>
+            <a:pPr algn="ctr"/>
+            <a:endParaRPr lang="en-US" dirty="0"/>
+          </a:p>
+          <a:p>
+            <a:pPr algn="ctr"/>
+            <a:endParaRPr lang="en-US" dirty="0"/>
+          </a:p>
+          <a:p>
+            <a:pPr algn="ctr"/>
+            <a:endParaRPr lang="en-US" dirty="0"/>
+          </a:p>
+        </p:txBody>
+      </p:sp>
+    </p:spTree>
+    <p:extLst>
+      <p:ext uri="{BB962C8B-B14F-4D97-AF65-F5344CB8AC3E}">
+        <p14:creationId xmlns:p14="http://schemas.microsoft.com/office/powerpoint/2010/main" val="2271184335"/>
       </p:ext>
     </p:extLst>
   </p:cSld>

</xml_diff>